<commit_message>
Sharpen presentation screenshots to 3840x2400 for full-slide legibility; fix analytics accuracy card on default filters; align forecast accuracy claims with live product
</commit_message>
<xml_diff>
--- a/presentation/BloodBridge-AI-Presentation.pptx
+++ b/presentation/BloodBridge-AI-Presentation.pptx
@@ -5816,7 +5816,7 @@
                   <a:srgbClr val="5B5B58"/>
                 </a:solidFill>
               </a:rPr>
-              <a:t>of demand forecast per city &amp; blood group, with backtested ~80–84% accuracy shown live</a:t>
+              <a:t>of demand forecast per city &amp; blood group — accuracy backtested daily against real demand, shown live</a:t>
             </a:r>
             <a:endParaRPr lang="en-US" sz="1000" dirty="0"/>
           </a:p>
@@ -7006,7 +7006,7 @@
                   <a:srgbClr val="0B4A44"/>
                 </a:solidFill>
               </a:rPr>
-              <a:t>The model is re-run on past days using only prior history, then compared with what actually happened — ~80–84% accuracy across 112 forecasts, displayed live in the product.</a:t>
+              <a:t>The model is re-run on past days using only prior history, then compared with what actually happened — accuracy across 672 backtested forecasts is displayed live in the product, per city and blood group.</a:t>
             </a:r>
             <a:endParaRPr lang="en-US" sz="1100" dirty="0"/>
           </a:p>

</xml_diff>